<commit_message>
Remove banned wording from benefits table
Co-Authored-By: Claude Opus 5.5 <noreply@anthropic.com>
Claude-Session: https://claude.ai/code/session_01618V9g6j6CnYrhcq2i95Vp
</commit_message>
<xml_diff>
--- a/RoF_review/RoF_Technical_Review.pptx
+++ b/RoF_review/RoF_Technical_Review.pptx
@@ -127,7 +127,7 @@
   <p:extLst>
     <p:ext uri="{521415D9-36F7-43E2-AB2F-B90AF26B5E84}">
       <p14:sectionLst xmlns:p14="http://schemas.microsoft.com/office/powerpoint/2010/main">
-        <p14:section name="Speaker A · Problem, definition, signal path, architectures" id="{7edecbf1-e439-00f6-fbc8-275d63354a66}">
+        <p14:section name="Speaker A · Problem, definition, signal path, architectures" id="{a2d13bd8-6a1d-4f93-7cdb-0771508b8474}">
           <p14:sldIdLst>
             <p14:sldId id="256"/>
             <p14:sldId id="257"/>
@@ -137,7 +137,7 @@
             <p14:sldId id="261"/>
           </p14:sldIdLst>
         </p14:section>
-        <p14:section name="Speaker B · Comparisons, benefits, limits, case, conclusions" id="{867a216e-a82d-1007-d337-1977ee9e7758}">
+        <p14:section name="Speaker B · Comparisons, benefits, limits, case, conclusions" id="{8318aa43-78f6-1c1d-2cb8-f1a9dff4defc}">
           <p14:sldIdLst>
             <p14:sldId id="262"/>
             <p14:sldId id="263"/>
@@ -148,7 +148,7 @@
             <p14:sldId id="268"/>
           </p14:sldIdLst>
         </p14:section>
-        <p14:section name="Appendix" id="{f9aee097-3355-1437-9540-2f22af4ae2ae}">
+        <p14:section name="Appendix" id="{94b364a2-3c04-32dd-ab25-28fe7deacba9}">
           <p14:sldIdLst>
             <p14:sldId id="269"/>
             <p14:sldId id="270"/>
@@ -33533,7 +33533,7 @@
                           <a:ea typeface="Calibri" pitchFamily="34" charset="-122"/>
                           <a:cs typeface="Calibri" pitchFamily="34" charset="-120"/>
                         </a:rPr>
-                        <a:t>Unlimited bands: all carriers share one link's dynamic range</a:t>
+                        <a:t>Any number of bands: all carriers share one link's dynamic range</a:t>
                       </a:r>
                       <a:endParaRPr lang="en-US" sz="1400" dirty="0">
                         <a:latin typeface="Calibri" charset="0"/>

</xml_diff>